<commit_message>
Kwalitijd: archive the final version with the two closing slides
Replace the deck and PDF with the version as presented, which adds
slide 21 (Infectieradar, with link and QR code) and slide 22 (the next
possibility, and taking versus sharing the gain at the threshold price
per QALY), and the author's new closing line. Update the README: the
storyline, the links to the repository, how the slides were made, and
the erratum slide number (21 -> 23).

Co-Authored-By: Claude Opus 5.5 <noreply@anthropic.com>
Claude-Session: https://claude.ai/code/session_017WZmokZxBhTVjDcUeAPwGW
</commit_message>
<xml_diff>
--- a/Presentations/2026-10-08-kwalitijd/Kwalitijd.pptx
+++ b/Presentations/2026-10-08-kwalitijd/Kwalitijd.pptx
@@ -5,7 +5,7 @@
     <p:sldMasterId id="2147483648" r:id="rId1"/>
   </p:sldMasterIdLst>
   <p:notesMasterIdLst>
-    <p:notesMasterId r:id="rId24"/>
+    <p:notesMasterId r:id="rId26"/>
   </p:notesMasterIdLst>
   <p:sldIdLst>
     <p:sldId id="256" r:id="rId2"/>
@@ -28,8 +28,10 @@
     <p:sldId id="273" r:id="rId19"/>
     <p:sldId id="274" r:id="rId20"/>
     <p:sldId id="275" r:id="rId21"/>
-    <p:sldId id="276" r:id="rId22"/>
-    <p:sldId id="277" r:id="rId23"/>
+    <p:sldId id="278" r:id="rId22"/>
+    <p:sldId id="279" r:id="rId23"/>
+    <p:sldId id="276" r:id="rId24"/>
+    <p:sldId id="277" r:id="rId25"/>
   </p:sldIdLst>
   <p:sldSz cx="12192000" cy="6858000"/>
   <p:notesSz cx="6858000" cy="12192000"/>
@@ -174,6 +176,8 @@
           <p14:sldIdLst>
             <p14:sldId id="274"/>
             <p14:sldId id="275"/>
+            <p14:sldId id="278"/>
+            <p14:sldId id="279"/>
             <p14:sldId id="276"/>
           </p14:sldIdLst>
         </p14:section>
@@ -2640,7 +2644,7 @@
           <a:p>
             <a:r>
               <a:rPr lang="en-US" dirty="0"/>
-              <a:t>[1:00] Ik eindig waar ik begon. Een bacterie kijkt minuten vooruit, een hond dagen, een mens decennia. Niemand ziet alles. Maar samen, als we eerlijk zijn over wat we zien en durven toe te geven wat we fout zagen, kunnen we generaties vooruitkijken. Samen modelleren is samen vooruitkijken, en samen vooruitkijken is samen leven. U kunt vanavond meedoen. Dank u wel.</a:t>
+              <a:t>[1:30] Dan een uitnodiging. Ik vertelde net dat we samen verder kijken dan alleen. Dat kunt u letterlijk doen. Ik ben projectleider van Infectieradar van het RIVM. Deelnemers vullen elke week een korte vragenlijst in: had u klachten van een infectie? Ook als het antwoord nee is, telt dat mee. Zo zien we wat er rondgaat, ook bij mensen die niet naar de huisarts gaan en dus in geen enkele andere registratie terechtkomen. Elke deelnemer voegt een kegel toe aan onze gezamenlijke kegel. Scan de code, of ga naar infectieradar.nl.</a:t>
             </a:r>
           </a:p>
         </p:txBody>
@@ -2727,7 +2731,7 @@
           <a:p>
             <a:r>
               <a:rPr lang="en-US" dirty="0"/>
-              <a:t>Achtergrond; niet presenteren.</a:t>
+              <a:t>[2:30] Waarom is dat belangrijk? Wat we vandaag kunnen, hangt af van wat er bestaat. Met geld koop je geen behandeling die nog niet bestaat. Die ontstaat pas als we samen kennis opbouwen. Meedoen levert kennis op, kennis maakt nieuwe interventies mogelijk, die leveren gezonde jaren op, en wie gezond is, kan weer bijdragen. Zo openen we steeds de volgende mogelijkheid. Maar dat werkt alleen als we de winst delen. En hier kom ik terug bij de prijs van een gezond jaar. Als gezondheidseconoom heb ik jarenlang uitgerekend tot welke prijs een vaccin nog kosteneffectief is. Die drempel is bedoeld als grens. In de praktijk wordt hij een richtprijs: een premie voor elk gewonnen levensjaar. Wie verkoopt, prijst tot aan de drempel. Wordt de uitvoering goedkoper, of zijn er minder doses nodig, dan mag de prijs zelfs omhoog. En betalen we de volle drempel, terwijl hetzelfde geld elders net zoveel gezondheid had opgeleverd, dan kopen we gezonde jaren, maar winnen we ze niet. Het andere spel: zo veel mogelijk mensen bereiken, voor een prijs dicht bij de kosten. Dan blijft de winst bij ons allemaal. Dat is nog steeds concurreren, maar op wat je bijdraagt, niet op wat je binnenhaalt. De wetenschap werkt al zo: je wint erkenning door weg te geven wat je vond.</a:t>
             </a:r>
           </a:p>
         </p:txBody>
@@ -2750,6 +2754,180 @@
             <a:fld id="{F7021451-1387-4CA6-816F-3879F97B5CBC}" type="slidenum">
               <a:rPr lang="en-US"/>
               <a:t>22</a:t>
+            </a:fld>
+            <a:endParaRPr lang="en-US"/>
+          </a:p>
+        </p:txBody>
+      </p:sp>
+    </p:spTree>
+    <p:extLst>
+      <p:ext uri="{BB962C8B-B14F-4D97-AF65-F5344CB8AC3E}">
+        <p14:creationId xmlns:p14="http://schemas.microsoft.com/office/powerpoint/2010/main" val="1024086991"/>
+      </p:ext>
+    </p:extLst>
+  </p:cSld>
+  <p:clrMapOvr>
+    <a:masterClrMapping/>
+  </p:clrMapOvr>
+</p:notes>
+</file>
+
+<file path=ppt/notesSlides/notesSlide23.xml><?xml version="1.0" encoding="utf-8"?>
+<p:notes xmlns:a="http://schemas.openxmlformats.org/drawingml/2006/main" xmlns:r="http://schemas.openxmlformats.org/officeDocument/2006/relationships" xmlns:p="http://schemas.openxmlformats.org/presentationml/2006/main">
+  <p:cSld>
+    <p:spTree>
+      <p:nvGrpSpPr>
+        <p:cNvPr id="1" name=""/>
+        <p:cNvGrpSpPr/>
+        <p:nvPr/>
+      </p:nvGrpSpPr>
+      <p:grpSpPr>
+        <a:xfrm>
+          <a:off x="0" y="0"/>
+          <a:ext cx="0" cy="0"/>
+          <a:chOff x="0" y="0"/>
+          <a:chExt cx="0" cy="0"/>
+        </a:xfrm>
+      </p:grpSpPr>
+      <p:sp>
+        <p:nvSpPr>
+          <p:cNvPr id="2" name="Slide Image Placeholder 1"/>
+          <p:cNvSpPr>
+            <a:spLocks noGrp="1" noRot="1" noChangeAspect="1"/>
+          </p:cNvSpPr>
+          <p:nvPr>
+            <p:ph type="sldImg"/>
+          </p:nvPr>
+        </p:nvSpPr>
+        <p:spPr/>
+      </p:sp>
+      <p:sp>
+        <p:nvSpPr>
+          <p:cNvPr id="3" name="Notes Placeholder 2"/>
+          <p:cNvSpPr>
+            <a:spLocks noGrp="1"/>
+          </p:cNvSpPr>
+          <p:nvPr>
+            <p:ph type="body" idx="1"/>
+          </p:nvPr>
+        </p:nvSpPr>
+        <p:spPr/>
+        <p:txBody>
+          <a:bodyPr/>
+          <a:lstStyle/>
+          <a:p>
+            <a:r>
+              <a:rPr lang="en-US" dirty="0"/>
+              <a:t>[1:00] Ik eindig waar ik begon. Een bacterie kijkt minuten vooruit, een hond dagen, een mens decennia. Niemand ziet alles. Maar samen, als we eerlijk zijn over wat we zien en durven toe te geven wat we fout zagen, kunnen we generaties vooruitkijken. Samen modelleren is samen vooruitkijken, en samen vooruitkijken is samen leven. U kunt vanavond meedoen. Dank u wel.</a:t>
+            </a:r>
+          </a:p>
+        </p:txBody>
+      </p:sp>
+      <p:sp>
+        <p:nvSpPr>
+          <p:cNvPr id="4" name="Slide Number Placeholder 3"/>
+          <p:cNvSpPr>
+            <a:spLocks noGrp="1"/>
+          </p:cNvSpPr>
+          <p:nvPr>
+            <p:ph type="sldNum" sz="quarter" idx="10"/>
+          </p:nvPr>
+        </p:nvSpPr>
+        <p:spPr/>
+        <p:txBody>
+          <a:bodyPr/>
+          <a:lstStyle/>
+          <a:p>
+            <a:fld id="{F7021451-1387-4CA6-816F-3879F97B5CBC}" type="slidenum">
+              <a:rPr lang="en-US"/>
+              <a:t>23</a:t>
+            </a:fld>
+            <a:endParaRPr lang="en-US"/>
+          </a:p>
+        </p:txBody>
+      </p:sp>
+    </p:spTree>
+    <p:extLst>
+      <p:ext uri="{BB962C8B-B14F-4D97-AF65-F5344CB8AC3E}">
+        <p14:creationId xmlns:p14="http://schemas.microsoft.com/office/powerpoint/2010/main" val="1024086991"/>
+      </p:ext>
+    </p:extLst>
+  </p:cSld>
+  <p:clrMapOvr>
+    <a:masterClrMapping/>
+  </p:clrMapOvr>
+</p:notes>
+</file>
+
+<file path=ppt/notesSlides/notesSlide24.xml><?xml version="1.0" encoding="utf-8"?>
+<p:notes xmlns:a="http://schemas.openxmlformats.org/drawingml/2006/main" xmlns:r="http://schemas.openxmlformats.org/officeDocument/2006/relationships" xmlns:p="http://schemas.openxmlformats.org/presentationml/2006/main">
+  <p:cSld>
+    <p:spTree>
+      <p:nvGrpSpPr>
+        <p:cNvPr id="1" name=""/>
+        <p:cNvGrpSpPr/>
+        <p:nvPr/>
+      </p:nvGrpSpPr>
+      <p:grpSpPr>
+        <a:xfrm>
+          <a:off x="0" y="0"/>
+          <a:ext cx="0" cy="0"/>
+          <a:chOff x="0" y="0"/>
+          <a:chExt cx="0" cy="0"/>
+        </a:xfrm>
+      </p:grpSpPr>
+      <p:sp>
+        <p:nvSpPr>
+          <p:cNvPr id="2" name="Slide Image Placeholder 1"/>
+          <p:cNvSpPr>
+            <a:spLocks noGrp="1" noRot="1" noChangeAspect="1"/>
+          </p:cNvSpPr>
+          <p:nvPr>
+            <p:ph type="sldImg"/>
+          </p:nvPr>
+        </p:nvSpPr>
+        <p:spPr/>
+      </p:sp>
+      <p:sp>
+        <p:nvSpPr>
+          <p:cNvPr id="3" name="Notes Placeholder 2"/>
+          <p:cNvSpPr>
+            <a:spLocks noGrp="1"/>
+          </p:cNvSpPr>
+          <p:nvPr>
+            <p:ph type="body" idx="1"/>
+          </p:nvPr>
+        </p:nvSpPr>
+        <p:spPr/>
+        <p:txBody>
+          <a:bodyPr/>
+          <a:lstStyle/>
+          <a:p>
+            <a:r>
+              <a:rPr lang="en-US" dirty="0"/>
+              <a:t>Achtergrond; niet presenteren.</a:t>
+            </a:r>
+          </a:p>
+        </p:txBody>
+      </p:sp>
+      <p:sp>
+        <p:nvSpPr>
+          <p:cNvPr id="4" name="Slide Number Placeholder 3"/>
+          <p:cNvSpPr>
+            <a:spLocks noGrp="1"/>
+          </p:cNvSpPr>
+          <p:nvPr>
+            <p:ph type="sldNum" sz="quarter" idx="10"/>
+          </p:nvPr>
+        </p:nvSpPr>
+        <p:spPr/>
+        <p:txBody>
+          <a:bodyPr/>
+          <a:lstStyle/>
+          <a:p>
+            <a:fld id="{F7021451-1387-4CA6-816F-3879F97B5CBC}" type="slidenum">
+              <a:rPr lang="en-US"/>
+              <a:t>24</a:t>
             </a:fld>
             <a:endParaRPr lang="en-US"/>
           </a:p>
@@ -3690,7 +3868,7 @@
           </a:prstGeom>
           <a:extLst>
             <a:ext uri="{C572A759-6A51-4108-AA02-DFA0A04FC94B}">
-              <ma14:wrappingTextBoxFlag xmlns:ma14="http://schemas.microsoft.com/office/mac/drawingml/2011/main" xmlns="" val="0"/>
+              <ma14:wrappingTextBoxFlag xmlns="" xmlns:ma14="http://schemas.microsoft.com/office/mac/drawingml/2011/main" val="0"/>
             </a:ext>
           </a:extLst>
         </p:spPr>
@@ -3913,7 +4091,7 @@
           </a:prstGeom>
           <a:extLst>
             <a:ext uri="{C572A759-6A51-4108-AA02-DFA0A04FC94B}">
-              <ma14:wrappingTextBoxFlag xmlns:ma14="http://schemas.microsoft.com/office/mac/drawingml/2011/main" xmlns="" val="0"/>
+              <ma14:wrappingTextBoxFlag xmlns="" xmlns:ma14="http://schemas.microsoft.com/office/mac/drawingml/2011/main" val="0"/>
             </a:ext>
           </a:extLst>
         </p:spPr>
@@ -5053,7 +5231,7 @@
           </a:prstGeom>
           <a:extLst>
             <a:ext uri="{C572A759-6A51-4108-AA02-DFA0A04FC94B}">
-              <ma14:wrappingTextBoxFlag xmlns:ma14="http://schemas.microsoft.com/office/mac/drawingml/2011/main" xmlns="" val="0"/>
+              <ma14:wrappingTextBoxFlag xmlns="" xmlns:ma14="http://schemas.microsoft.com/office/mac/drawingml/2011/main" val="0"/>
             </a:ext>
           </a:extLst>
         </p:spPr>
@@ -5794,7 +5972,7 @@
           </a:prstGeom>
           <a:extLst>
             <a:ext uri="{C572A759-6A51-4108-AA02-DFA0A04FC94B}">
-              <ma14:wrappingTextBoxFlag xmlns:ma14="http://schemas.microsoft.com/office/mac/drawingml/2011/main" xmlns="" val="0"/>
+              <ma14:wrappingTextBoxFlag xmlns="" xmlns:ma14="http://schemas.microsoft.com/office/mac/drawingml/2011/main" val="0"/>
             </a:ext>
           </a:extLst>
         </p:spPr>
@@ -6777,7 +6955,7 @@
           </a:prstGeom>
           <a:extLst>
             <a:ext uri="{C572A759-6A51-4108-AA02-DFA0A04FC94B}">
-              <ma14:wrappingTextBoxFlag xmlns:ma14="http://schemas.microsoft.com/office/mac/drawingml/2011/main" xmlns="" val="0"/>
+              <ma14:wrappingTextBoxFlag xmlns="" xmlns:ma14="http://schemas.microsoft.com/office/mac/drawingml/2011/main" val="0"/>
             </a:ext>
           </a:extLst>
         </p:spPr>
@@ -7519,7 +7697,7 @@
           </a:prstGeom>
           <a:extLst>
             <a:ext uri="{C572A759-6A51-4108-AA02-DFA0A04FC94B}">
-              <ma14:wrappingTextBoxFlag xmlns:ma14="http://schemas.microsoft.com/office/mac/drawingml/2011/main" xmlns="" val="0"/>
+              <ma14:wrappingTextBoxFlag xmlns="" xmlns:ma14="http://schemas.microsoft.com/office/mac/drawingml/2011/main" val="0"/>
             </a:ext>
           </a:extLst>
         </p:spPr>
@@ -8221,7 +8399,7 @@
           </a:prstGeom>
           <a:extLst>
             <a:ext uri="{C572A759-6A51-4108-AA02-DFA0A04FC94B}">
-              <ma14:wrappingTextBoxFlag xmlns:ma14="http://schemas.microsoft.com/office/mac/drawingml/2011/main" xmlns="" val="0"/>
+              <ma14:wrappingTextBoxFlag xmlns="" xmlns:ma14="http://schemas.microsoft.com/office/mac/drawingml/2011/main" val="0"/>
             </a:ext>
           </a:extLst>
         </p:spPr>
@@ -8832,7 +9010,7 @@
           </a:prstGeom>
           <a:extLst>
             <a:ext uri="{C572A759-6A51-4108-AA02-DFA0A04FC94B}">
-              <ma14:wrappingTextBoxFlag xmlns:ma14="http://schemas.microsoft.com/office/mac/drawingml/2011/main" xmlns="" val="0"/>
+              <ma14:wrappingTextBoxFlag xmlns="" xmlns:ma14="http://schemas.microsoft.com/office/mac/drawingml/2011/main" val="0"/>
             </a:ext>
           </a:extLst>
         </p:spPr>
@@ -10030,7 +10208,7 @@
           </a:prstGeom>
           <a:extLst>
             <a:ext uri="{C572A759-6A51-4108-AA02-DFA0A04FC94B}">
-              <ma14:wrappingTextBoxFlag xmlns:ma14="http://schemas.microsoft.com/office/mac/drawingml/2011/main" xmlns="" val="0"/>
+              <ma14:wrappingTextBoxFlag xmlns="" xmlns:ma14="http://schemas.microsoft.com/office/mac/drawingml/2011/main" val="0"/>
             </a:ext>
           </a:extLst>
         </p:spPr>
@@ -10064,6 +10242,1995 @@
 </file>
 
 <file path=ppt/slides/slide21.xml><?xml version="1.0" encoding="utf-8"?>
+<p:sld xmlns:a="http://schemas.openxmlformats.org/drawingml/2006/main" xmlns:r="http://schemas.openxmlformats.org/officeDocument/2006/relationships" xmlns:p="http://schemas.openxmlformats.org/presentationml/2006/main">
+  <p:cSld name="Slide 1">
+    <p:spTree>
+      <p:nvGrpSpPr>
+        <p:cNvPr id="1" name=""/>
+        <p:cNvGrpSpPr/>
+        <p:nvPr/>
+      </p:nvGrpSpPr>
+      <p:grpSpPr>
+        <a:xfrm>
+          <a:off x="0" y="0"/>
+          <a:ext cx="0" cy="0"/>
+          <a:chOff x="0" y="0"/>
+          <a:chExt cx="0" cy="0"/>
+        </a:xfrm>
+      </p:grpSpPr>
+      <p:sp>
+        <p:nvSpPr>
+          <p:cNvPr id="2" name="Text 0"/>
+          <p:cNvSpPr>
+            <a:spLocks noGrp="1"/>
+          </p:cNvSpPr>
+          <p:nvPr>
+            <p:ph type="body" idx="100" hasCustomPrompt="1"/>
+          </p:nvPr>
+        </p:nvSpPr>
+        <p:spPr>
+          <a:xfrm>
+            <a:off x="667512" y="256032"/>
+            <a:ext cx="10856671" cy="292608"/>
+          </a:xfrm>
+          <a:prstGeom prst="rect">
+            <a:avLst/>
+          </a:prstGeom>
+          <a:noFill/>
+          <a:ln/>
+        </p:spPr>
+        <p:txBody>
+          <a:bodyPr wrap="square" lIns="0" tIns="0" rIns="0" bIns="0" rtlCol="0" anchor="t"/>
+          <a:lstStyle/>
+          <a:p>
+            <a:pPr marL="0" indent="0">
+              <a:buNone/>
+            </a:pPr>
+            <a:r>
+              <a:rPr lang="en-US" sz="1100" b="1" dirty="0">
+                <a:solidFill>
+                  <a:schemeClr val="accent1"/>
+                </a:solidFill>
+              </a:rPr>
+              <a:t>DOE MEE</a:t>
+            </a:r>
+            <a:endParaRPr lang="en-US" sz="1100" dirty="0"/>
+          </a:p>
+        </p:txBody>
+      </p:sp>
+      <p:sp>
+        <p:nvSpPr>
+          <p:cNvPr id="3" name="Text 0"/>
+          <p:cNvSpPr>
+            <a:spLocks noGrp="1"/>
+          </p:cNvSpPr>
+          <p:nvPr>
+            <p:ph type="title" idx="101" hasCustomPrompt="1"/>
+          </p:nvPr>
+        </p:nvSpPr>
+        <p:spPr>
+          <a:xfrm>
+            <a:off x="667512" y="548640"/>
+            <a:ext cx="10856671" cy="566928"/>
+          </a:xfrm>
+          <a:prstGeom prst="rect">
+            <a:avLst/>
+          </a:prstGeom>
+          <a:noFill/>
+          <a:ln/>
+        </p:spPr>
+        <p:txBody>
+          <a:bodyPr wrap="square" lIns="0" tIns="0" rIns="0" bIns="0" rtlCol="0" anchor="ctr"/>
+          <a:lstStyle/>
+          <a:p>
+            <a:pPr marL="0" indent="0" algn="l">
+              <a:buNone/>
+            </a:pPr>
+            <a:r>
+              <a:rPr lang="en-US" dirty="0"/>
+              <a:t>Doe</a:t>
+            </a:r>
+            <a:r>
+              <a:rPr lang="en-US" sz="2800" b="1" dirty="0">
+                <a:solidFill>
+                  <a:schemeClr val="tx1"/>
+                </a:solidFill>
+              </a:rPr>
+              <a:t> mee: Infectieradar</a:t>
+            </a:r>
+            <a:endParaRPr lang="en-US" sz="2800" dirty="0"/>
+          </a:p>
+        </p:txBody>
+      </p:sp>
+      <p:sp>
+        <p:nvSpPr>
+          <p:cNvPr id="4" name="Text 0"/>
+          <p:cNvSpPr>
+            <a:spLocks noGrp="1"/>
+          </p:cNvSpPr>
+          <p:nvPr>
+            <p:ph type="body" idx="102" hasCustomPrompt="1"/>
+          </p:nvPr>
+        </p:nvSpPr>
+        <p:spPr>
+          <a:xfrm>
+            <a:off x="667512" y="1133856"/>
+            <a:ext cx="10856671" cy="384048"/>
+          </a:xfrm>
+          <a:prstGeom prst="rect">
+            <a:avLst/>
+          </a:prstGeom>
+          <a:noFill/>
+          <a:ln/>
+        </p:spPr>
+        <p:txBody>
+          <a:bodyPr wrap="square" lIns="0" tIns="0" rIns="0" bIns="0" rtlCol="0" anchor="t"/>
+          <a:lstStyle/>
+          <a:p>
+            <a:pPr marL="0" indent="0">
+              <a:buNone/>
+            </a:pPr>
+            <a:r>
+              <a:rPr lang="en-US" sz="1500" dirty="0">
+                <a:solidFill>
+                  <a:schemeClr val="tx2"/>
+                </a:solidFill>
+              </a:rPr>
+              <a:t>Een </a:t>
+            </a:r>
+            <a:r>
+              <a:rPr lang="en-US" sz="1500" dirty="0" err="1">
+                <a:solidFill>
+                  <a:schemeClr val="tx2"/>
+                </a:solidFill>
+              </a:rPr>
+              <a:t>gezamenlijke</a:t>
+            </a:r>
+            <a:r>
+              <a:rPr lang="en-US" sz="1500" dirty="0">
+                <a:solidFill>
+                  <a:schemeClr val="tx2"/>
+                </a:solidFill>
+              </a:rPr>
+              <a:t> </a:t>
+            </a:r>
+            <a:r>
+              <a:rPr lang="en-US" dirty="0" err="1"/>
+              <a:t>onderzoek</a:t>
+            </a:r>
+            <a:r>
+              <a:rPr lang="en-US" sz="1500" dirty="0">
+                <a:solidFill>
+                  <a:schemeClr val="tx2"/>
+                </a:solidFill>
+              </a:rPr>
+              <a:t> bouwen we met z'n allen: elke </a:t>
+            </a:r>
+            <a:r>
+              <a:rPr lang="en-US" sz="1500" dirty="0" err="1">
+                <a:solidFill>
+                  <a:schemeClr val="tx2"/>
+                </a:solidFill>
+              </a:rPr>
+              <a:t>deelnemer</a:t>
+            </a:r>
+            <a:r>
+              <a:rPr lang="en-US" sz="1500" dirty="0">
+                <a:solidFill>
+                  <a:schemeClr val="tx2"/>
+                </a:solidFill>
+              </a:rPr>
+              <a:t> </a:t>
+            </a:r>
+            <a:r>
+              <a:rPr lang="en-US" sz="1500" dirty="0" err="1">
+                <a:solidFill>
+                  <a:schemeClr val="tx2"/>
+                </a:solidFill>
+              </a:rPr>
+              <a:t>doet</a:t>
+            </a:r>
+            <a:r>
+              <a:rPr lang="en-US" sz="1500" dirty="0">
+                <a:solidFill>
+                  <a:schemeClr val="tx2"/>
+                </a:solidFill>
+              </a:rPr>
+              <a:t> </a:t>
+            </a:r>
+            <a:r>
+              <a:rPr lang="en-US" sz="1500" dirty="0" err="1">
+                <a:solidFill>
+                  <a:schemeClr val="tx2"/>
+                </a:solidFill>
+              </a:rPr>
+              <a:t>en</a:t>
+            </a:r>
+            <a:r>
+              <a:rPr lang="en-US" sz="1500" dirty="0">
+                <a:solidFill>
+                  <a:schemeClr val="tx2"/>
+                </a:solidFill>
+              </a:rPr>
+              <a:t> </a:t>
+            </a:r>
+            <a:r>
+              <a:rPr lang="en-US" sz="1500" dirty="0" err="1">
+                <a:solidFill>
+                  <a:schemeClr val="tx2"/>
+                </a:solidFill>
+              </a:rPr>
+              <a:t>kijkt</a:t>
+            </a:r>
+            <a:r>
+              <a:rPr lang="en-US" sz="1500" dirty="0">
+                <a:solidFill>
+                  <a:schemeClr val="tx2"/>
+                </a:solidFill>
+              </a:rPr>
+              <a:t> mee</a:t>
+            </a:r>
+            <a:endParaRPr lang="en-US" sz="1500" dirty="0"/>
+          </a:p>
+        </p:txBody>
+      </p:sp>
+      <p:sp>
+        <p:nvSpPr>
+          <p:cNvPr id="5" name="Meld je aan"/>
+          <p:cNvSpPr/>
+          <p:nvPr/>
+        </p:nvSpPr>
+        <p:spPr>
+          <a:xfrm>
+            <a:off x="667512" y="1783080"/>
+            <a:ext cx="6583680" cy="1188720"/>
+          </a:xfrm>
+          <a:prstGeom prst="roundRect">
+            <a:avLst>
+              <a:gd name="adj" fmla="val 9231"/>
+            </a:avLst>
+          </a:prstGeom>
+          <a:solidFill>
+            <a:schemeClr val="bg2"/>
+          </a:solidFill>
+          <a:ln/>
+        </p:spPr>
+        <p:txBody>
+          <a:bodyPr/>
+          <a:lstStyle/>
+          <a:p>
+            <a:endParaRPr lang="en-US"/>
+          </a:p>
+        </p:txBody>
+      </p:sp>
+      <p:sp>
+        <p:nvSpPr>
+          <p:cNvPr id="6" name="Nummer 1"/>
+          <p:cNvSpPr/>
+          <p:nvPr/>
+        </p:nvSpPr>
+        <p:spPr>
+          <a:xfrm>
+            <a:off x="941832" y="2148840"/>
+            <a:ext cx="457200" cy="457200"/>
+          </a:xfrm>
+          <a:prstGeom prst="ellipse">
+            <a:avLst/>
+          </a:prstGeom>
+          <a:solidFill>
+            <a:schemeClr val="accent1"/>
+          </a:solidFill>
+          <a:ln/>
+        </p:spPr>
+        <p:txBody>
+          <a:bodyPr/>
+          <a:lstStyle/>
+          <a:p>
+            <a:endParaRPr lang="en-US"/>
+          </a:p>
+        </p:txBody>
+      </p:sp>
+      <p:sp>
+        <p:nvSpPr>
+          <p:cNvPr id="7" name="Text 5"/>
+          <p:cNvSpPr txBox="1"/>
+          <p:nvPr/>
+        </p:nvSpPr>
+        <p:spPr>
+          <a:xfrm>
+            <a:off x="941832" y="2148840"/>
+            <a:ext cx="457200" cy="457200"/>
+          </a:xfrm>
+          <a:prstGeom prst="rect">
+            <a:avLst/>
+          </a:prstGeom>
+          <a:noFill/>
+          <a:ln/>
+        </p:spPr>
+        <p:txBody>
+          <a:bodyPr wrap="square" lIns="0" tIns="0" rIns="0" bIns="0" rtlCol="0" anchor="ctr"/>
+          <a:lstStyle/>
+          <a:p>
+            <a:pPr marL="0" indent="0" algn="ctr">
+              <a:buNone/>
+            </a:pPr>
+            <a:r>
+              <a:rPr lang="en-US" sz="1800" b="1" dirty="0">
+                <a:solidFill>
+                  <a:schemeClr val="bg1"/>
+                </a:solidFill>
+              </a:rPr>
+              <a:t>1</a:t>
+            </a:r>
+            <a:endParaRPr lang="en-US" sz="1800" dirty="0"/>
+          </a:p>
+        </p:txBody>
+      </p:sp>
+      <p:sp>
+        <p:nvSpPr>
+          <p:cNvPr id="8" name="Text 6"/>
+          <p:cNvSpPr txBox="1"/>
+          <p:nvPr/>
+        </p:nvSpPr>
+        <p:spPr>
+          <a:xfrm>
+            <a:off x="1627632" y="1938528"/>
+            <a:ext cx="5349240" cy="457200"/>
+          </a:xfrm>
+          <a:prstGeom prst="rect">
+            <a:avLst/>
+          </a:prstGeom>
+          <a:noFill/>
+          <a:ln/>
+        </p:spPr>
+        <p:txBody>
+          <a:bodyPr wrap="square" lIns="0" tIns="0" rIns="0" bIns="0" rtlCol="0" anchor="ctr"/>
+          <a:lstStyle/>
+          <a:p>
+            <a:pPr marL="0" indent="0">
+              <a:buNone/>
+            </a:pPr>
+            <a:r>
+              <a:rPr lang="en-US" sz="1800" b="1" dirty="0">
+                <a:solidFill>
+                  <a:schemeClr val="tx1"/>
+                </a:solidFill>
+              </a:rPr>
+              <a:t>Meld je aan</a:t>
+            </a:r>
+            <a:endParaRPr lang="en-US" sz="1800" dirty="0"/>
+          </a:p>
+        </p:txBody>
+      </p:sp>
+      <p:sp>
+        <p:nvSpPr>
+          <p:cNvPr id="9" name="Text 7"/>
+          <p:cNvSpPr txBox="1"/>
+          <p:nvPr/>
+        </p:nvSpPr>
+        <p:spPr>
+          <a:xfrm>
+            <a:off x="1627632" y="2395728"/>
+            <a:ext cx="5349240" cy="457200"/>
+          </a:xfrm>
+          <a:prstGeom prst="rect">
+            <a:avLst/>
+          </a:prstGeom>
+          <a:noFill/>
+          <a:ln/>
+        </p:spPr>
+        <p:txBody>
+          <a:bodyPr wrap="square" lIns="0" tIns="0" rIns="0" bIns="0" rtlCol="0" anchor="t"/>
+          <a:lstStyle/>
+          <a:p>
+            <a:pPr marL="0" indent="0">
+              <a:buNone/>
+            </a:pPr>
+            <a:r>
+              <a:rPr lang="en-US" sz="1500" dirty="0">
+                <a:solidFill>
+                  <a:schemeClr val="tx2"/>
+                </a:solidFill>
+              </a:rPr>
+              <a:t>Ga naar infectieradar.nl, of scan de code.</a:t>
+            </a:r>
+            <a:endParaRPr lang="en-US" sz="1500" dirty="0"/>
+          </a:p>
+        </p:txBody>
+      </p:sp>
+      <p:sp>
+        <p:nvSpPr>
+          <p:cNvPr id="10" name="Elke week een korte vragenlijst"/>
+          <p:cNvSpPr/>
+          <p:nvPr/>
+        </p:nvSpPr>
+        <p:spPr>
+          <a:xfrm>
+            <a:off x="667512" y="3200400"/>
+            <a:ext cx="6583680" cy="1188720"/>
+          </a:xfrm>
+          <a:prstGeom prst="roundRect">
+            <a:avLst>
+              <a:gd name="adj" fmla="val 9231"/>
+            </a:avLst>
+          </a:prstGeom>
+          <a:solidFill>
+            <a:schemeClr val="bg2"/>
+          </a:solidFill>
+          <a:ln/>
+        </p:spPr>
+        <p:txBody>
+          <a:bodyPr/>
+          <a:lstStyle/>
+          <a:p>
+            <a:endParaRPr lang="en-US"/>
+          </a:p>
+        </p:txBody>
+      </p:sp>
+      <p:sp>
+        <p:nvSpPr>
+          <p:cNvPr id="11" name="Nummer 2"/>
+          <p:cNvSpPr/>
+          <p:nvPr/>
+        </p:nvSpPr>
+        <p:spPr>
+          <a:xfrm>
+            <a:off x="941832" y="3566160"/>
+            <a:ext cx="457200" cy="457200"/>
+          </a:xfrm>
+          <a:prstGeom prst="ellipse">
+            <a:avLst/>
+          </a:prstGeom>
+          <a:solidFill>
+            <a:schemeClr val="accent2"/>
+          </a:solidFill>
+          <a:ln/>
+        </p:spPr>
+        <p:txBody>
+          <a:bodyPr/>
+          <a:lstStyle/>
+          <a:p>
+            <a:endParaRPr lang="en-US"/>
+          </a:p>
+        </p:txBody>
+      </p:sp>
+      <p:sp>
+        <p:nvSpPr>
+          <p:cNvPr id="12" name="Text 10"/>
+          <p:cNvSpPr txBox="1"/>
+          <p:nvPr/>
+        </p:nvSpPr>
+        <p:spPr>
+          <a:xfrm>
+            <a:off x="941832" y="3566160"/>
+            <a:ext cx="457200" cy="457200"/>
+          </a:xfrm>
+          <a:prstGeom prst="rect">
+            <a:avLst/>
+          </a:prstGeom>
+          <a:noFill/>
+          <a:ln/>
+        </p:spPr>
+        <p:txBody>
+          <a:bodyPr wrap="square" lIns="0" tIns="0" rIns="0" bIns="0" rtlCol="0" anchor="ctr"/>
+          <a:lstStyle/>
+          <a:p>
+            <a:pPr marL="0" indent="0" algn="ctr">
+              <a:buNone/>
+            </a:pPr>
+            <a:r>
+              <a:rPr lang="en-US" sz="1800" b="1" dirty="0">
+                <a:solidFill>
+                  <a:schemeClr val="bg1"/>
+                </a:solidFill>
+              </a:rPr>
+              <a:t>2</a:t>
+            </a:r>
+            <a:endParaRPr lang="en-US" sz="1800" dirty="0"/>
+          </a:p>
+        </p:txBody>
+      </p:sp>
+      <p:sp>
+        <p:nvSpPr>
+          <p:cNvPr id="13" name="Text 11"/>
+          <p:cNvSpPr txBox="1"/>
+          <p:nvPr/>
+        </p:nvSpPr>
+        <p:spPr>
+          <a:xfrm>
+            <a:off x="1627632" y="3355848"/>
+            <a:ext cx="5349240" cy="457200"/>
+          </a:xfrm>
+          <a:prstGeom prst="rect">
+            <a:avLst/>
+          </a:prstGeom>
+          <a:noFill/>
+          <a:ln/>
+        </p:spPr>
+        <p:txBody>
+          <a:bodyPr wrap="square" lIns="0" tIns="0" rIns="0" bIns="0" rtlCol="0" anchor="ctr"/>
+          <a:lstStyle/>
+          <a:p>
+            <a:pPr marL="0" indent="0">
+              <a:buNone/>
+            </a:pPr>
+            <a:r>
+              <a:rPr lang="en-US" sz="1800" b="1" dirty="0">
+                <a:solidFill>
+                  <a:schemeClr val="tx1"/>
+                </a:solidFill>
+              </a:rPr>
+              <a:t>Elke week een korte vragenlijst</a:t>
+            </a:r>
+            <a:endParaRPr lang="en-US" sz="1800" dirty="0"/>
+          </a:p>
+        </p:txBody>
+      </p:sp>
+      <p:sp>
+        <p:nvSpPr>
+          <p:cNvPr id="14" name="Text 12"/>
+          <p:cNvSpPr txBox="1"/>
+          <p:nvPr/>
+        </p:nvSpPr>
+        <p:spPr>
+          <a:xfrm>
+            <a:off x="1627632" y="3813048"/>
+            <a:ext cx="5349240" cy="457200"/>
+          </a:xfrm>
+          <a:prstGeom prst="rect">
+            <a:avLst/>
+          </a:prstGeom>
+          <a:noFill/>
+          <a:ln/>
+        </p:spPr>
+        <p:txBody>
+          <a:bodyPr wrap="square" lIns="0" tIns="0" rIns="0" bIns="0" rtlCol="0" anchor="t"/>
+          <a:lstStyle/>
+          <a:p>
+            <a:pPr marL="0" indent="0">
+              <a:buNone/>
+            </a:pPr>
+            <a:r>
+              <a:rPr lang="en-US" sz="1500" dirty="0">
+                <a:solidFill>
+                  <a:schemeClr val="tx2"/>
+                </a:solidFill>
+              </a:rPr>
+              <a:t>Had je klachten van een infectie? Ook ‘nee’ telt mee.</a:t>
+            </a:r>
+            <a:endParaRPr lang="en-US" sz="1500" dirty="0"/>
+          </a:p>
+        </p:txBody>
+      </p:sp>
+      <p:sp>
+        <p:nvSpPr>
+          <p:cNvPr id="15" name="Samen zien we meer"/>
+          <p:cNvSpPr/>
+          <p:nvPr/>
+        </p:nvSpPr>
+        <p:spPr>
+          <a:xfrm>
+            <a:off x="667512" y="4617720"/>
+            <a:ext cx="6583680" cy="1188720"/>
+          </a:xfrm>
+          <a:prstGeom prst="roundRect">
+            <a:avLst>
+              <a:gd name="adj" fmla="val 9231"/>
+            </a:avLst>
+          </a:prstGeom>
+          <a:solidFill>
+            <a:schemeClr val="bg2"/>
+          </a:solidFill>
+          <a:ln/>
+        </p:spPr>
+        <p:txBody>
+          <a:bodyPr/>
+          <a:lstStyle/>
+          <a:p>
+            <a:endParaRPr lang="en-US"/>
+          </a:p>
+        </p:txBody>
+      </p:sp>
+      <p:sp>
+        <p:nvSpPr>
+          <p:cNvPr id="16" name="Nummer 3"/>
+          <p:cNvSpPr/>
+          <p:nvPr/>
+        </p:nvSpPr>
+        <p:spPr>
+          <a:xfrm>
+            <a:off x="941832" y="4983480"/>
+            <a:ext cx="457200" cy="457200"/>
+          </a:xfrm>
+          <a:prstGeom prst="ellipse">
+            <a:avLst/>
+          </a:prstGeom>
+          <a:solidFill>
+            <a:schemeClr val="accent6"/>
+          </a:solidFill>
+          <a:ln/>
+        </p:spPr>
+        <p:txBody>
+          <a:bodyPr/>
+          <a:lstStyle/>
+          <a:p>
+            <a:endParaRPr lang="en-US"/>
+          </a:p>
+        </p:txBody>
+      </p:sp>
+      <p:sp>
+        <p:nvSpPr>
+          <p:cNvPr id="17" name="Text 15"/>
+          <p:cNvSpPr txBox="1"/>
+          <p:nvPr/>
+        </p:nvSpPr>
+        <p:spPr>
+          <a:xfrm>
+            <a:off x="941832" y="4983480"/>
+            <a:ext cx="457200" cy="457200"/>
+          </a:xfrm>
+          <a:prstGeom prst="rect">
+            <a:avLst/>
+          </a:prstGeom>
+          <a:noFill/>
+          <a:ln/>
+        </p:spPr>
+        <p:txBody>
+          <a:bodyPr wrap="square" lIns="0" tIns="0" rIns="0" bIns="0" rtlCol="0" anchor="ctr"/>
+          <a:lstStyle/>
+          <a:p>
+            <a:pPr marL="0" indent="0" algn="ctr">
+              <a:buNone/>
+            </a:pPr>
+            <a:r>
+              <a:rPr lang="en-US" sz="1800" b="1" dirty="0">
+                <a:solidFill>
+                  <a:schemeClr val="bg1"/>
+                </a:solidFill>
+              </a:rPr>
+              <a:t>3</a:t>
+            </a:r>
+            <a:endParaRPr lang="en-US" sz="1800" dirty="0"/>
+          </a:p>
+        </p:txBody>
+      </p:sp>
+      <p:sp>
+        <p:nvSpPr>
+          <p:cNvPr id="18" name="Text 16"/>
+          <p:cNvSpPr txBox="1"/>
+          <p:nvPr/>
+        </p:nvSpPr>
+        <p:spPr>
+          <a:xfrm>
+            <a:off x="1627632" y="4773168"/>
+            <a:ext cx="5349240" cy="457200"/>
+          </a:xfrm>
+          <a:prstGeom prst="rect">
+            <a:avLst/>
+          </a:prstGeom>
+          <a:noFill/>
+          <a:ln/>
+        </p:spPr>
+        <p:txBody>
+          <a:bodyPr wrap="square" lIns="0" tIns="0" rIns="0" bIns="0" rtlCol="0" anchor="ctr"/>
+          <a:lstStyle/>
+          <a:p>
+            <a:pPr marL="0" indent="0">
+              <a:buNone/>
+            </a:pPr>
+            <a:r>
+              <a:rPr lang="en-US" sz="1800" b="1" dirty="0">
+                <a:solidFill>
+                  <a:schemeClr val="tx1"/>
+                </a:solidFill>
+              </a:rPr>
+              <a:t>Samen zien we meer</a:t>
+            </a:r>
+            <a:endParaRPr lang="en-US" sz="1800" dirty="0"/>
+          </a:p>
+        </p:txBody>
+      </p:sp>
+      <p:sp>
+        <p:nvSpPr>
+          <p:cNvPr id="19" name="Text 17"/>
+          <p:cNvSpPr txBox="1"/>
+          <p:nvPr/>
+        </p:nvSpPr>
+        <p:spPr>
+          <a:xfrm>
+            <a:off x="1627632" y="5230368"/>
+            <a:ext cx="5349240" cy="457200"/>
+          </a:xfrm>
+          <a:prstGeom prst="rect">
+            <a:avLst/>
+          </a:prstGeom>
+          <a:noFill/>
+          <a:ln/>
+        </p:spPr>
+        <p:txBody>
+          <a:bodyPr wrap="square" lIns="0" tIns="0" rIns="0" bIns="0" rtlCol="0" anchor="t"/>
+          <a:lstStyle/>
+          <a:p>
+            <a:pPr marL="0" indent="0">
+              <a:buNone/>
+            </a:pPr>
+            <a:r>
+              <a:rPr lang="en-US" sz="1500" dirty="0">
+                <a:solidFill>
+                  <a:schemeClr val="tx2"/>
+                </a:solidFill>
+              </a:rPr>
+              <a:t>Ook wie niet naar de huisarts gaat, wordt zo gezien.</a:t>
+            </a:r>
+            <a:endParaRPr lang="en-US" sz="1500" dirty="0"/>
+          </a:p>
+        </p:txBody>
+      </p:sp>
+      <p:sp>
+        <p:nvSpPr>
+          <p:cNvPr id="20" name="Infectieradar QR"/>
+          <p:cNvSpPr/>
+          <p:nvPr/>
+        </p:nvSpPr>
+        <p:spPr>
+          <a:xfrm>
+            <a:off x="7662672" y="1783080"/>
+            <a:ext cx="3861511" cy="4023360"/>
+          </a:xfrm>
+          <a:prstGeom prst="roundRect">
+            <a:avLst>
+              <a:gd name="adj" fmla="val 2842"/>
+            </a:avLst>
+          </a:prstGeom>
+          <a:solidFill>
+            <a:schemeClr val="tx1"/>
+          </a:solidFill>
+          <a:ln/>
+        </p:spPr>
+        <p:txBody>
+          <a:bodyPr/>
+          <a:lstStyle/>
+          <a:p>
+            <a:endParaRPr lang="en-US"/>
+          </a:p>
+        </p:txBody>
+      </p:sp>
+      <p:sp>
+        <p:nvSpPr>
+          <p:cNvPr id="21" name="QR achtergrond"/>
+          <p:cNvSpPr/>
+          <p:nvPr/>
+        </p:nvSpPr>
+        <p:spPr>
+          <a:xfrm>
+            <a:off x="8221828" y="2057400"/>
+            <a:ext cx="2743200" cy="2743200"/>
+          </a:xfrm>
+          <a:prstGeom prst="roundRect">
+            <a:avLst>
+              <a:gd name="adj" fmla="val 2667"/>
+            </a:avLst>
+          </a:prstGeom>
+          <a:solidFill>
+            <a:srgbClr val="FFFFFF"/>
+          </a:solidFill>
+          <a:ln/>
+        </p:spPr>
+        <p:txBody>
+          <a:bodyPr/>
+          <a:lstStyle/>
+          <a:p>
+            <a:endParaRPr lang="en-US"/>
+          </a:p>
+        </p:txBody>
+      </p:sp>
+      <p:pic>
+        <p:nvPicPr>
+          <p:cNvPr id="22" name="QR-code" descr="QR-code naar infectieradar.nl"/>
+          <p:cNvPicPr>
+            <a:picLocks noChangeAspect="1"/>
+          </p:cNvPicPr>
+          <p:nvPr/>
+        </p:nvPicPr>
+        <p:blipFill>
+          <a:blip r:embed="rId3"/>
+          <a:stretch>
+            <a:fillRect/>
+          </a:stretch>
+        </p:blipFill>
+        <p:spPr>
+          <a:xfrm>
+            <a:off x="8358988" y="2194560"/>
+            <a:ext cx="2468880" cy="2468880"/>
+          </a:xfrm>
+          <a:prstGeom prst="rect">
+            <a:avLst/>
+          </a:prstGeom>
+        </p:spPr>
+      </p:pic>
+      <p:sp>
+        <p:nvSpPr>
+          <p:cNvPr id="23" name="Text 20"/>
+          <p:cNvSpPr txBox="1"/>
+          <p:nvPr/>
+        </p:nvSpPr>
+        <p:spPr>
+          <a:xfrm>
+            <a:off x="7936992" y="4983480"/>
+            <a:ext cx="3312871" cy="457200"/>
+          </a:xfrm>
+          <a:prstGeom prst="rect">
+            <a:avLst/>
+          </a:prstGeom>
+          <a:noFill/>
+          <a:ln/>
+        </p:spPr>
+        <p:txBody>
+          <a:bodyPr wrap="square" lIns="0" tIns="0" rIns="0" bIns="0" rtlCol="0" anchor="ctr"/>
+          <a:lstStyle/>
+          <a:p>
+            <a:pPr marL="0" indent="0" algn="ctr">
+              <a:buNone/>
+            </a:pPr>
+            <a:r>
+              <a:rPr lang="en-US" sz="2400" b="1" u="sng" dirty="0">
+                <a:solidFill>
+                  <a:schemeClr val="bg1"/>
+                </a:solidFill>
+                <a:hlinkClick r:id="rId4" tooltip="Infectieradar">
+                  <a:extLst>
+                    <a:ext uri="{A12FA001-AC4F-418D-AE19-62706E023703}">
+                      <ahyp:hlinkClr xmlns:ahyp="http://schemas.microsoft.com/office/drawing/2018/hyperlinkcolor" val="tx"/>
+                    </a:ext>
+                  </a:extLst>
+                </a:hlinkClick>
+              </a:rPr>
+              <a:t>infectieradar.nl</a:t>
+            </a:r>
+            <a:endParaRPr lang="en-US" sz="2400" dirty="0"/>
+          </a:p>
+        </p:txBody>
+      </p:sp>
+      <p:sp>
+        <p:nvSpPr>
+          <p:cNvPr id="24" name="Text 21"/>
+          <p:cNvSpPr txBox="1"/>
+          <p:nvPr/>
+        </p:nvSpPr>
+        <p:spPr>
+          <a:xfrm>
+            <a:off x="7936992" y="5394960"/>
+            <a:ext cx="3312871" cy="320040"/>
+          </a:xfrm>
+          <a:prstGeom prst="rect">
+            <a:avLst/>
+          </a:prstGeom>
+          <a:noFill/>
+          <a:ln/>
+        </p:spPr>
+        <p:txBody>
+          <a:bodyPr wrap="square" lIns="0" tIns="0" rIns="0" bIns="0" rtlCol="0" anchor="t"/>
+          <a:lstStyle/>
+          <a:p>
+            <a:pPr marL="0" indent="0" algn="ctr">
+              <a:buNone/>
+            </a:pPr>
+            <a:r>
+              <a:rPr lang="en-US" sz="1300" dirty="0">
+                <a:solidFill>
+                  <a:schemeClr val="bg2"/>
+                </a:solidFill>
+              </a:rPr>
+              <a:t>Een project van het RIVM</a:t>
+            </a:r>
+            <a:endParaRPr lang="en-US" sz="1300" dirty="0"/>
+          </a:p>
+        </p:txBody>
+      </p:sp>
+      <p:sp>
+        <p:nvSpPr>
+          <p:cNvPr id="25" name="Slide Number Placeholder 0"/>
+          <p:cNvSpPr>
+            <a:spLocks noGrp="1"/>
+          </p:cNvSpPr>
+          <p:nvPr>
+            <p:ph type="sldNum" sz="quarter" idx="4294967295"/>
+          </p:nvPr>
+        </p:nvSpPr>
+        <p:spPr>
+          <a:xfrm>
+            <a:off x="11384280" y="6473952"/>
+            <a:ext cx="457200" cy="228600"/>
+          </a:xfrm>
+          <a:prstGeom prst="rect">
+            <a:avLst/>
+          </a:prstGeom>
+          <a:extLst>
+            <a:ext uri="{C572A759-6A51-4108-AA02-DFA0A04FC94B}">
+              <ma14:wrappingTextBoxFlag xmlns:ma14="http://schemas.microsoft.com/office/mac/drawingml/2011/main" xmlns="" val="0"/>
+            </a:ext>
+          </a:extLst>
+        </p:spPr>
+        <p:txBody>
+          <a:bodyPr/>
+          <a:lstStyle>
+            <a:lvl1pPr>
+              <a:defRPr sz="900">
+                <a:solidFill>
+                  <a:srgbClr val="556675"/>
+                </a:solidFill>
+              </a:defRPr>
+            </a:lvl1pPr>
+          </a:lstStyle>
+          <a:p>
+            <a:pPr algn="r"/>
+            <a:fld id="{F7021451-1387-4CA6-816F-3879F97B5CBC}" type="slidenum">
+              <a:rPr lang="en-US" b="0"/>
+              <a:t>21</a:t>
+            </a:fld>
+            <a:endParaRPr lang="en-US"/>
+          </a:p>
+        </p:txBody>
+      </p:sp>
+    </p:spTree>
+  </p:cSld>
+  <p:clrMapOvr>
+    <a:masterClrMapping/>
+  </p:clrMapOvr>
+</p:sld>
+</file>
+
+<file path=ppt/slides/slide22.xml><?xml version="1.0" encoding="utf-8"?>
+<p:sld xmlns:a="http://schemas.openxmlformats.org/drawingml/2006/main" xmlns:r="http://schemas.openxmlformats.org/officeDocument/2006/relationships" xmlns:p="http://schemas.openxmlformats.org/presentationml/2006/main">
+  <p:cSld name="Slide 2">
+    <p:spTree>
+      <p:nvGrpSpPr>
+        <p:cNvPr id="1" name=""/>
+        <p:cNvGrpSpPr/>
+        <p:nvPr/>
+      </p:nvGrpSpPr>
+      <p:grpSpPr>
+        <a:xfrm>
+          <a:off x="0" y="0"/>
+          <a:ext cx="0" cy="0"/>
+          <a:chOff x="0" y="0"/>
+          <a:chExt cx="0" cy="0"/>
+        </a:xfrm>
+      </p:grpSpPr>
+      <p:sp>
+        <p:nvSpPr>
+          <p:cNvPr id="2" name="Text 0"/>
+          <p:cNvSpPr>
+            <a:spLocks noGrp="1"/>
+          </p:cNvSpPr>
+          <p:nvPr>
+            <p:ph type="body" idx="100" hasCustomPrompt="1"/>
+          </p:nvPr>
+        </p:nvSpPr>
+        <p:spPr>
+          <a:xfrm>
+            <a:off x="667512" y="256032"/>
+            <a:ext cx="10856671" cy="292608"/>
+          </a:xfrm>
+          <a:prstGeom prst="rect">
+            <a:avLst/>
+          </a:prstGeom>
+          <a:noFill/>
+          <a:ln/>
+        </p:spPr>
+        <p:txBody>
+          <a:bodyPr wrap="square" lIns="0" tIns="0" rIns="0" bIns="0" rtlCol="0" anchor="t"/>
+          <a:lstStyle/>
+          <a:p>
+            <a:pPr marL="0" indent="0">
+              <a:buNone/>
+            </a:pPr>
+            <a:r>
+              <a:rPr lang="en-US" sz="1100" b="1" dirty="0">
+                <a:solidFill>
+                  <a:schemeClr val="accent1"/>
+                </a:solidFill>
+              </a:rPr>
+              <a:t>DE VOLGENDE MOGELIJKHEID</a:t>
+            </a:r>
+            <a:endParaRPr lang="en-US" sz="1100" dirty="0"/>
+          </a:p>
+        </p:txBody>
+      </p:sp>
+      <p:sp>
+        <p:nvSpPr>
+          <p:cNvPr id="3" name="Text 0"/>
+          <p:cNvSpPr>
+            <a:spLocks noGrp="1"/>
+          </p:cNvSpPr>
+          <p:nvPr>
+            <p:ph type="title" idx="101" hasCustomPrompt="1"/>
+          </p:nvPr>
+        </p:nvSpPr>
+        <p:spPr>
+          <a:xfrm>
+            <a:off x="667512" y="548640"/>
+            <a:ext cx="10856671" cy="566928"/>
+          </a:xfrm>
+          <a:prstGeom prst="rect">
+            <a:avLst/>
+          </a:prstGeom>
+          <a:noFill/>
+          <a:ln/>
+        </p:spPr>
+        <p:txBody>
+          <a:bodyPr wrap="square" lIns="0" tIns="0" rIns="0" bIns="0" rtlCol="0" anchor="ctr"/>
+          <a:lstStyle/>
+          <a:p>
+            <a:pPr marL="0" indent="0" algn="l">
+              <a:buNone/>
+            </a:pPr>
+            <a:r>
+              <a:rPr lang="en-US" sz="2800" b="1" dirty="0">
+                <a:solidFill>
+                  <a:schemeClr val="tx1"/>
+                </a:solidFill>
+              </a:rPr>
+              <a:t>Samen openen we wat straks kan</a:t>
+            </a:r>
+            <a:endParaRPr lang="en-US" sz="2800" dirty="0"/>
+          </a:p>
+        </p:txBody>
+      </p:sp>
+      <p:sp>
+        <p:nvSpPr>
+          <p:cNvPr id="4" name="Text 0"/>
+          <p:cNvSpPr>
+            <a:spLocks noGrp="1"/>
+          </p:cNvSpPr>
+          <p:nvPr>
+            <p:ph type="body" idx="102" hasCustomPrompt="1"/>
+          </p:nvPr>
+        </p:nvSpPr>
+        <p:spPr>
+          <a:xfrm>
+            <a:off x="667512" y="1133856"/>
+            <a:ext cx="10856671" cy="384048"/>
+          </a:xfrm>
+          <a:prstGeom prst="rect">
+            <a:avLst/>
+          </a:prstGeom>
+          <a:noFill/>
+          <a:ln/>
+        </p:spPr>
+        <p:txBody>
+          <a:bodyPr wrap="square" lIns="0" tIns="0" rIns="0" bIns="0" rtlCol="0" anchor="t"/>
+          <a:lstStyle/>
+          <a:p>
+            <a:pPr marL="0" indent="0">
+              <a:buNone/>
+            </a:pPr>
+            <a:r>
+              <a:rPr lang="en-US" sz="1500" dirty="0">
+                <a:solidFill>
+                  <a:schemeClr val="tx2"/>
+                </a:solidFill>
+              </a:rPr>
+              <a:t>Geld koopt geen behandeling die nog niet bestaat. Die ontstaat pas als we kennis opbouwen en delen.</a:t>
+            </a:r>
+            <a:endParaRPr lang="en-US" sz="1500" dirty="0"/>
+          </a:p>
+        </p:txBody>
+      </p:sp>
+      <p:sp>
+        <p:nvSpPr>
+          <p:cNvPr id="5" name="Meedoen"/>
+          <p:cNvSpPr/>
+          <p:nvPr/>
+        </p:nvSpPr>
+        <p:spPr>
+          <a:xfrm>
+            <a:off x="667512" y="1783080"/>
+            <a:ext cx="2371268" cy="1371600"/>
+          </a:xfrm>
+          <a:prstGeom prst="roundRect">
+            <a:avLst>
+              <a:gd name="adj" fmla="val 8000"/>
+            </a:avLst>
+          </a:prstGeom>
+          <a:solidFill>
+            <a:schemeClr val="bg2"/>
+          </a:solidFill>
+          <a:ln/>
+        </p:spPr>
+        <p:txBody>
+          <a:bodyPr/>
+          <a:lstStyle/>
+          <a:p>
+            <a:endParaRPr lang="en-US"/>
+          </a:p>
+        </p:txBody>
+      </p:sp>
+      <p:sp>
+        <p:nvSpPr>
+          <p:cNvPr id="6" name="Stip Meedoen"/>
+          <p:cNvSpPr/>
+          <p:nvPr/>
+        </p:nvSpPr>
+        <p:spPr>
+          <a:xfrm>
+            <a:off x="896112" y="2057400"/>
+            <a:ext cx="219456" cy="219456"/>
+          </a:xfrm>
+          <a:prstGeom prst="ellipse">
+            <a:avLst/>
+          </a:prstGeom>
+          <a:solidFill>
+            <a:schemeClr val="accent1"/>
+          </a:solidFill>
+          <a:ln/>
+        </p:spPr>
+        <p:txBody>
+          <a:bodyPr/>
+          <a:lstStyle/>
+          <a:p>
+            <a:endParaRPr lang="en-US"/>
+          </a:p>
+        </p:txBody>
+      </p:sp>
+      <p:sp>
+        <p:nvSpPr>
+          <p:cNvPr id="7" name="Text 5"/>
+          <p:cNvSpPr txBox="1"/>
+          <p:nvPr/>
+        </p:nvSpPr>
+        <p:spPr>
+          <a:xfrm>
+            <a:off x="1234440" y="1965960"/>
+            <a:ext cx="1639748" cy="411480"/>
+          </a:xfrm>
+          <a:prstGeom prst="rect">
+            <a:avLst/>
+          </a:prstGeom>
+          <a:noFill/>
+          <a:ln/>
+        </p:spPr>
+        <p:txBody>
+          <a:bodyPr wrap="square" lIns="0" tIns="0" rIns="0" bIns="0" rtlCol="0" anchor="ctr"/>
+          <a:lstStyle/>
+          <a:p>
+            <a:pPr marL="0" indent="0">
+              <a:buNone/>
+            </a:pPr>
+            <a:r>
+              <a:rPr lang="en-US" sz="1700" b="1" dirty="0">
+                <a:solidFill>
+                  <a:schemeClr val="tx1"/>
+                </a:solidFill>
+              </a:rPr>
+              <a:t>Meedoen</a:t>
+            </a:r>
+            <a:endParaRPr lang="en-US" sz="1700" dirty="0"/>
+          </a:p>
+        </p:txBody>
+      </p:sp>
+      <p:sp>
+        <p:nvSpPr>
+          <p:cNvPr id="8" name="Text 6"/>
+          <p:cNvSpPr txBox="1"/>
+          <p:nvPr/>
+        </p:nvSpPr>
+        <p:spPr>
+          <a:xfrm>
+            <a:off x="896112" y="2468880"/>
+            <a:ext cx="1959788" cy="594360"/>
+          </a:xfrm>
+          <a:prstGeom prst="rect">
+            <a:avLst/>
+          </a:prstGeom>
+          <a:noFill/>
+          <a:ln/>
+        </p:spPr>
+        <p:txBody>
+          <a:bodyPr wrap="square" lIns="0" tIns="0" rIns="0" bIns="0" rtlCol="0" anchor="t"/>
+          <a:lstStyle/>
+          <a:p>
+            <a:pPr marL="0" indent="0">
+              <a:buNone/>
+            </a:pPr>
+            <a:r>
+              <a:rPr lang="en-US" sz="1400" dirty="0">
+                <a:solidFill>
+                  <a:schemeClr val="tx2"/>
+                </a:solidFill>
+              </a:rPr>
+              <a:t>Gegevens, ervaring, een eerlijke blik</a:t>
+            </a:r>
+            <a:endParaRPr lang="en-US" sz="1400" dirty="0"/>
+          </a:p>
+        </p:txBody>
+      </p:sp>
+      <p:sp>
+        <p:nvSpPr>
+          <p:cNvPr id="9" name="Pijl 1"/>
+          <p:cNvSpPr/>
+          <p:nvPr/>
+        </p:nvSpPr>
+        <p:spPr>
+          <a:xfrm>
+            <a:off x="3130220" y="2331720"/>
+            <a:ext cx="274320" cy="274320"/>
+          </a:xfrm>
+          <a:prstGeom prst="rightArrow">
+            <a:avLst/>
+          </a:prstGeom>
+          <a:solidFill>
+            <a:schemeClr val="tx2"/>
+          </a:solidFill>
+          <a:ln/>
+        </p:spPr>
+        <p:txBody>
+          <a:bodyPr/>
+          <a:lstStyle/>
+          <a:p>
+            <a:endParaRPr lang="en-US"/>
+          </a:p>
+        </p:txBody>
+      </p:sp>
+      <p:sp>
+        <p:nvSpPr>
+          <p:cNvPr id="10" name="Kennis"/>
+          <p:cNvSpPr/>
+          <p:nvPr/>
+        </p:nvSpPr>
+        <p:spPr>
+          <a:xfrm>
+            <a:off x="3495980" y="1783080"/>
+            <a:ext cx="2371268" cy="1371600"/>
+          </a:xfrm>
+          <a:prstGeom prst="roundRect">
+            <a:avLst>
+              <a:gd name="adj" fmla="val 8000"/>
+            </a:avLst>
+          </a:prstGeom>
+          <a:solidFill>
+            <a:schemeClr val="bg2"/>
+          </a:solidFill>
+          <a:ln/>
+        </p:spPr>
+        <p:txBody>
+          <a:bodyPr/>
+          <a:lstStyle/>
+          <a:p>
+            <a:endParaRPr lang="en-US"/>
+          </a:p>
+        </p:txBody>
+      </p:sp>
+      <p:sp>
+        <p:nvSpPr>
+          <p:cNvPr id="11" name="Stip Kennis"/>
+          <p:cNvSpPr/>
+          <p:nvPr/>
+        </p:nvSpPr>
+        <p:spPr>
+          <a:xfrm>
+            <a:off x="3724580" y="2057400"/>
+            <a:ext cx="219456" cy="219456"/>
+          </a:xfrm>
+          <a:prstGeom prst="ellipse">
+            <a:avLst/>
+          </a:prstGeom>
+          <a:solidFill>
+            <a:schemeClr val="accent2"/>
+          </a:solidFill>
+          <a:ln/>
+        </p:spPr>
+        <p:txBody>
+          <a:bodyPr/>
+          <a:lstStyle/>
+          <a:p>
+            <a:endParaRPr lang="en-US"/>
+          </a:p>
+        </p:txBody>
+      </p:sp>
+      <p:sp>
+        <p:nvSpPr>
+          <p:cNvPr id="12" name="Text 10"/>
+          <p:cNvSpPr txBox="1"/>
+          <p:nvPr/>
+        </p:nvSpPr>
+        <p:spPr>
+          <a:xfrm>
+            <a:off x="4062908" y="1965960"/>
+            <a:ext cx="1639748" cy="411480"/>
+          </a:xfrm>
+          <a:prstGeom prst="rect">
+            <a:avLst/>
+          </a:prstGeom>
+          <a:noFill/>
+          <a:ln/>
+        </p:spPr>
+        <p:txBody>
+          <a:bodyPr wrap="square" lIns="0" tIns="0" rIns="0" bIns="0" rtlCol="0" anchor="ctr"/>
+          <a:lstStyle/>
+          <a:p>
+            <a:pPr marL="0" indent="0">
+              <a:buNone/>
+            </a:pPr>
+            <a:r>
+              <a:rPr lang="en-US" sz="1700" b="1" dirty="0">
+                <a:solidFill>
+                  <a:schemeClr val="tx1"/>
+                </a:solidFill>
+              </a:rPr>
+              <a:t>Kennis</a:t>
+            </a:r>
+            <a:endParaRPr lang="en-US" sz="1700" dirty="0"/>
+          </a:p>
+        </p:txBody>
+      </p:sp>
+      <p:sp>
+        <p:nvSpPr>
+          <p:cNvPr id="13" name="Text 11"/>
+          <p:cNvSpPr txBox="1"/>
+          <p:nvPr/>
+        </p:nvSpPr>
+        <p:spPr>
+          <a:xfrm>
+            <a:off x="3724580" y="2468880"/>
+            <a:ext cx="1959788" cy="594360"/>
+          </a:xfrm>
+          <a:prstGeom prst="rect">
+            <a:avLst/>
+          </a:prstGeom>
+          <a:noFill/>
+          <a:ln/>
+        </p:spPr>
+        <p:txBody>
+          <a:bodyPr wrap="square" lIns="0" tIns="0" rIns="0" bIns="0" rtlCol="0" anchor="t"/>
+          <a:lstStyle/>
+          <a:p>
+            <a:pPr marL="0" indent="0">
+              <a:buNone/>
+            </a:pPr>
+            <a:r>
+              <a:rPr lang="en-US" sz="1400" dirty="0">
+                <a:solidFill>
+                  <a:schemeClr val="tx2"/>
+                </a:solidFill>
+              </a:rPr>
+              <a:t>We zien wat er rondgaat en wat werkt</a:t>
+            </a:r>
+            <a:endParaRPr lang="en-US" sz="1400" dirty="0"/>
+          </a:p>
+        </p:txBody>
+      </p:sp>
+      <p:sp>
+        <p:nvSpPr>
+          <p:cNvPr id="14" name="Pijl 2"/>
+          <p:cNvSpPr/>
+          <p:nvPr/>
+        </p:nvSpPr>
+        <p:spPr>
+          <a:xfrm>
+            <a:off x="5958688" y="2331720"/>
+            <a:ext cx="274320" cy="274320"/>
+          </a:xfrm>
+          <a:prstGeom prst="rightArrow">
+            <a:avLst/>
+          </a:prstGeom>
+          <a:solidFill>
+            <a:schemeClr val="tx2"/>
+          </a:solidFill>
+          <a:ln/>
+        </p:spPr>
+        <p:txBody>
+          <a:bodyPr/>
+          <a:lstStyle/>
+          <a:p>
+            <a:endParaRPr lang="en-US"/>
+          </a:p>
+        </p:txBody>
+      </p:sp>
+      <p:sp>
+        <p:nvSpPr>
+          <p:cNvPr id="15" name="Interventies"/>
+          <p:cNvSpPr/>
+          <p:nvPr/>
+        </p:nvSpPr>
+        <p:spPr>
+          <a:xfrm>
+            <a:off x="6324448" y="1783080"/>
+            <a:ext cx="2371268" cy="1371600"/>
+          </a:xfrm>
+          <a:prstGeom prst="roundRect">
+            <a:avLst>
+              <a:gd name="adj" fmla="val 8000"/>
+            </a:avLst>
+          </a:prstGeom>
+          <a:solidFill>
+            <a:schemeClr val="bg2"/>
+          </a:solidFill>
+          <a:ln/>
+        </p:spPr>
+        <p:txBody>
+          <a:bodyPr/>
+          <a:lstStyle/>
+          <a:p>
+            <a:endParaRPr lang="en-US"/>
+          </a:p>
+        </p:txBody>
+      </p:sp>
+      <p:sp>
+        <p:nvSpPr>
+          <p:cNvPr id="16" name="Stip Interventies"/>
+          <p:cNvSpPr/>
+          <p:nvPr/>
+        </p:nvSpPr>
+        <p:spPr>
+          <a:xfrm>
+            <a:off x="6553048" y="2057400"/>
+            <a:ext cx="219456" cy="219456"/>
+          </a:xfrm>
+          <a:prstGeom prst="ellipse">
+            <a:avLst/>
+          </a:prstGeom>
+          <a:solidFill>
+            <a:schemeClr val="accent6"/>
+          </a:solidFill>
+          <a:ln/>
+        </p:spPr>
+        <p:txBody>
+          <a:bodyPr/>
+          <a:lstStyle/>
+          <a:p>
+            <a:endParaRPr lang="en-US"/>
+          </a:p>
+        </p:txBody>
+      </p:sp>
+      <p:sp>
+        <p:nvSpPr>
+          <p:cNvPr id="17" name="Text 15"/>
+          <p:cNvSpPr txBox="1"/>
+          <p:nvPr/>
+        </p:nvSpPr>
+        <p:spPr>
+          <a:xfrm>
+            <a:off x="6891376" y="1965960"/>
+            <a:ext cx="1639748" cy="411480"/>
+          </a:xfrm>
+          <a:prstGeom prst="rect">
+            <a:avLst/>
+          </a:prstGeom>
+          <a:noFill/>
+          <a:ln/>
+        </p:spPr>
+        <p:txBody>
+          <a:bodyPr wrap="square" lIns="0" tIns="0" rIns="0" bIns="0" rtlCol="0" anchor="ctr"/>
+          <a:lstStyle/>
+          <a:p>
+            <a:pPr marL="0" indent="0">
+              <a:buNone/>
+            </a:pPr>
+            <a:r>
+              <a:rPr lang="en-US" sz="1700" b="1" dirty="0">
+                <a:solidFill>
+                  <a:schemeClr val="tx1"/>
+                </a:solidFill>
+              </a:rPr>
+              <a:t>Interventies</a:t>
+            </a:r>
+            <a:endParaRPr lang="en-US" sz="1700" dirty="0"/>
+          </a:p>
+        </p:txBody>
+      </p:sp>
+      <p:sp>
+        <p:nvSpPr>
+          <p:cNvPr id="18" name="Text 16"/>
+          <p:cNvSpPr txBox="1"/>
+          <p:nvPr/>
+        </p:nvSpPr>
+        <p:spPr>
+          <a:xfrm>
+            <a:off x="6553048" y="2468880"/>
+            <a:ext cx="1959788" cy="594360"/>
+          </a:xfrm>
+          <a:prstGeom prst="rect">
+            <a:avLst/>
+          </a:prstGeom>
+          <a:noFill/>
+          <a:ln/>
+        </p:spPr>
+        <p:txBody>
+          <a:bodyPr wrap="square" lIns="0" tIns="0" rIns="0" bIns="0" rtlCol="0" anchor="t"/>
+          <a:lstStyle/>
+          <a:p>
+            <a:pPr marL="0" indent="0">
+              <a:buNone/>
+            </a:pPr>
+            <a:r>
+              <a:rPr lang="en-US" sz="1400" dirty="0">
+                <a:solidFill>
+                  <a:schemeClr val="tx2"/>
+                </a:solidFill>
+              </a:rPr>
+              <a:t>Gerichter vaccineren, testen en zorgen</a:t>
+            </a:r>
+            <a:endParaRPr lang="en-US" sz="1400" dirty="0"/>
+          </a:p>
+        </p:txBody>
+      </p:sp>
+      <p:sp>
+        <p:nvSpPr>
+          <p:cNvPr id="19" name="Pijl 3"/>
+          <p:cNvSpPr/>
+          <p:nvPr/>
+        </p:nvSpPr>
+        <p:spPr>
+          <a:xfrm>
+            <a:off x="8787155" y="2331720"/>
+            <a:ext cx="274320" cy="274320"/>
+          </a:xfrm>
+          <a:prstGeom prst="rightArrow">
+            <a:avLst/>
+          </a:prstGeom>
+          <a:solidFill>
+            <a:schemeClr val="tx2"/>
+          </a:solidFill>
+          <a:ln/>
+        </p:spPr>
+        <p:txBody>
+          <a:bodyPr/>
+          <a:lstStyle/>
+          <a:p>
+            <a:endParaRPr lang="en-US"/>
+          </a:p>
+        </p:txBody>
+      </p:sp>
+      <p:sp>
+        <p:nvSpPr>
+          <p:cNvPr id="20" name="Gezonde jaren"/>
+          <p:cNvSpPr/>
+          <p:nvPr/>
+        </p:nvSpPr>
+        <p:spPr>
+          <a:xfrm>
+            <a:off x="9152915" y="1783080"/>
+            <a:ext cx="2371268" cy="1371600"/>
+          </a:xfrm>
+          <a:prstGeom prst="roundRect">
+            <a:avLst>
+              <a:gd name="adj" fmla="val 8000"/>
+            </a:avLst>
+          </a:prstGeom>
+          <a:solidFill>
+            <a:schemeClr val="bg2"/>
+          </a:solidFill>
+          <a:ln/>
+        </p:spPr>
+        <p:txBody>
+          <a:bodyPr/>
+          <a:lstStyle/>
+          <a:p>
+            <a:endParaRPr lang="en-US"/>
+          </a:p>
+        </p:txBody>
+      </p:sp>
+      <p:sp>
+        <p:nvSpPr>
+          <p:cNvPr id="21" name="Stip Gezonde jaren"/>
+          <p:cNvSpPr/>
+          <p:nvPr/>
+        </p:nvSpPr>
+        <p:spPr>
+          <a:xfrm>
+            <a:off x="9381515" y="2057400"/>
+            <a:ext cx="219456" cy="219456"/>
+          </a:xfrm>
+          <a:prstGeom prst="ellipse">
+            <a:avLst/>
+          </a:prstGeom>
+          <a:solidFill>
+            <a:schemeClr val="accent4"/>
+          </a:solidFill>
+          <a:ln/>
+        </p:spPr>
+        <p:txBody>
+          <a:bodyPr/>
+          <a:lstStyle/>
+          <a:p>
+            <a:endParaRPr lang="en-US"/>
+          </a:p>
+        </p:txBody>
+      </p:sp>
+      <p:sp>
+        <p:nvSpPr>
+          <p:cNvPr id="22" name="Text 20"/>
+          <p:cNvSpPr txBox="1"/>
+          <p:nvPr/>
+        </p:nvSpPr>
+        <p:spPr>
+          <a:xfrm>
+            <a:off x="9719843" y="1965960"/>
+            <a:ext cx="1639748" cy="411480"/>
+          </a:xfrm>
+          <a:prstGeom prst="rect">
+            <a:avLst/>
+          </a:prstGeom>
+          <a:noFill/>
+          <a:ln/>
+        </p:spPr>
+        <p:txBody>
+          <a:bodyPr wrap="square" lIns="0" tIns="0" rIns="0" bIns="0" rtlCol="0" anchor="ctr"/>
+          <a:lstStyle/>
+          <a:p>
+            <a:pPr marL="0" indent="0">
+              <a:buNone/>
+            </a:pPr>
+            <a:r>
+              <a:rPr lang="en-US" sz="1700" b="1" dirty="0">
+                <a:solidFill>
+                  <a:schemeClr val="tx1"/>
+                </a:solidFill>
+              </a:rPr>
+              <a:t>Gezonde jaren</a:t>
+            </a:r>
+            <a:endParaRPr lang="en-US" sz="1700" dirty="0"/>
+          </a:p>
+        </p:txBody>
+      </p:sp>
+      <p:sp>
+        <p:nvSpPr>
+          <p:cNvPr id="23" name="Text 21"/>
+          <p:cNvSpPr txBox="1"/>
+          <p:nvPr/>
+        </p:nvSpPr>
+        <p:spPr>
+          <a:xfrm>
+            <a:off x="9381515" y="2468880"/>
+            <a:ext cx="1959788" cy="594360"/>
+          </a:xfrm>
+          <a:prstGeom prst="rect">
+            <a:avLst/>
+          </a:prstGeom>
+          <a:noFill/>
+          <a:ln/>
+        </p:spPr>
+        <p:txBody>
+          <a:bodyPr wrap="square" lIns="0" tIns="0" rIns="0" bIns="0" rtlCol="0" anchor="t"/>
+          <a:lstStyle/>
+          <a:p>
+            <a:pPr marL="0" indent="0">
+              <a:buNone/>
+            </a:pPr>
+            <a:r>
+              <a:rPr lang="en-US" sz="1400" dirty="0">
+                <a:solidFill>
+                  <a:schemeClr val="tx2"/>
+                </a:solidFill>
+              </a:rPr>
+              <a:t>En meer ruimte om weer bij te dragen</a:t>
+            </a:r>
+            <a:endParaRPr lang="en-US" sz="1400" dirty="0"/>
+          </a:p>
+        </p:txBody>
+      </p:sp>
+      <p:sp>
+        <p:nvSpPr>
+          <p:cNvPr id="24" name="Terugkoppeling"/>
+          <p:cNvSpPr/>
+          <p:nvPr/>
+        </p:nvSpPr>
+        <p:spPr>
+          <a:xfrm>
+            <a:off x="1853146" y="3319272"/>
+            <a:ext cx="8485403" cy="237744"/>
+          </a:xfrm>
+          <a:prstGeom prst="leftArrow">
+            <a:avLst/>
+          </a:prstGeom>
+          <a:solidFill>
+            <a:schemeClr val="accent2">
+              <a:alpha val="65000"/>
+            </a:schemeClr>
+          </a:solidFill>
+          <a:ln/>
+        </p:spPr>
+        <p:txBody>
+          <a:bodyPr/>
+          <a:lstStyle/>
+          <a:p>
+            <a:endParaRPr lang="en-US"/>
+          </a:p>
+        </p:txBody>
+      </p:sp>
+      <p:sp>
+        <p:nvSpPr>
+          <p:cNvPr id="25" name="Text 23"/>
+          <p:cNvSpPr txBox="1"/>
+          <p:nvPr/>
+        </p:nvSpPr>
+        <p:spPr>
+          <a:xfrm>
+            <a:off x="1853146" y="3611880"/>
+            <a:ext cx="8485403" cy="320040"/>
+          </a:xfrm>
+          <a:prstGeom prst="rect">
+            <a:avLst/>
+          </a:prstGeom>
+          <a:noFill/>
+          <a:ln/>
+        </p:spPr>
+        <p:txBody>
+          <a:bodyPr wrap="square" lIns="0" tIns="0" rIns="0" bIns="0" rtlCol="0" anchor="t"/>
+          <a:lstStyle/>
+          <a:p>
+            <a:pPr marL="0" indent="0" algn="ctr">
+              <a:buNone/>
+            </a:pPr>
+            <a:r>
+              <a:rPr lang="en-US" sz="1500" i="1" dirty="0">
+                <a:solidFill>
+                  <a:schemeClr val="accent2"/>
+                </a:solidFill>
+              </a:rPr>
+              <a:t>… en dat opent de volgende mogelijkheid</a:t>
+            </a:r>
+            <a:endParaRPr lang="en-US" sz="1500" dirty="0"/>
+          </a:p>
+        </p:txBody>
+      </p:sp>
+      <p:sp>
+        <p:nvSpPr>
+          <p:cNvPr id="26" name="Winst nemen"/>
+          <p:cNvSpPr/>
+          <p:nvPr/>
+        </p:nvSpPr>
+        <p:spPr>
+          <a:xfrm>
+            <a:off x="667512" y="4069080"/>
+            <a:ext cx="5245456" cy="2011680"/>
+          </a:xfrm>
+          <a:prstGeom prst="roundRect">
+            <a:avLst>
+              <a:gd name="adj" fmla="val 5455"/>
+            </a:avLst>
+          </a:prstGeom>
+          <a:solidFill>
+            <a:schemeClr val="bg2"/>
+          </a:solidFill>
+          <a:ln/>
+        </p:spPr>
+        <p:txBody>
+          <a:bodyPr/>
+          <a:lstStyle/>
+          <a:p>
+            <a:endParaRPr lang="en-US"/>
+          </a:p>
+        </p:txBody>
+      </p:sp>
+      <p:sp>
+        <p:nvSpPr>
+          <p:cNvPr id="27" name="Text 25"/>
+          <p:cNvSpPr txBox="1"/>
+          <p:nvPr/>
+        </p:nvSpPr>
+        <p:spPr>
+          <a:xfrm>
+            <a:off x="987552" y="4270248"/>
+            <a:ext cx="4605376" cy="457200"/>
+          </a:xfrm>
+          <a:prstGeom prst="rect">
+            <a:avLst/>
+          </a:prstGeom>
+          <a:noFill/>
+          <a:ln/>
+        </p:spPr>
+        <p:txBody>
+          <a:bodyPr wrap="square" lIns="0" tIns="0" rIns="0" bIns="0" rtlCol="0" anchor="ctr"/>
+          <a:lstStyle/>
+          <a:p>
+            <a:pPr marL="0" indent="0">
+              <a:buNone/>
+            </a:pPr>
+            <a:r>
+              <a:rPr lang="en-US" sz="1800" b="1" dirty="0">
+                <a:solidFill>
+                  <a:schemeClr val="tx1"/>
+                </a:solidFill>
+              </a:rPr>
+              <a:t>Winst nemen: de prijs tot aan de drempel</a:t>
+            </a:r>
+            <a:endParaRPr lang="en-US" sz="1800" dirty="0"/>
+          </a:p>
+        </p:txBody>
+      </p:sp>
+      <p:sp>
+        <p:nvSpPr>
+          <p:cNvPr id="28" name="Text 26"/>
+          <p:cNvSpPr txBox="1"/>
+          <p:nvPr/>
+        </p:nvSpPr>
+        <p:spPr>
+          <a:xfrm>
+            <a:off x="987552" y="4800600"/>
+            <a:ext cx="4605376" cy="1143000"/>
+          </a:xfrm>
+          <a:prstGeom prst="rect">
+            <a:avLst/>
+          </a:prstGeom>
+          <a:noFill/>
+          <a:ln/>
+        </p:spPr>
+        <p:txBody>
+          <a:bodyPr wrap="square" lIns="0" tIns="0" rIns="0" bIns="0" rtlCol="0" anchor="t"/>
+          <a:lstStyle/>
+          <a:p>
+            <a:pPr marL="0" indent="0">
+              <a:buNone/>
+            </a:pPr>
+            <a:r>
+              <a:rPr lang="en-US" sz="1500" dirty="0">
+                <a:solidFill>
+                  <a:schemeClr val="tx2"/>
+                </a:solidFill>
+              </a:rPr>
+              <a:t>Dan kopen we gezonde jaren, maar winnen we ze niet: hetzelfde geld had elders evenveel gezondheid opgeleverd. De drempel per QALY werkt dan als een premie.</a:t>
+            </a:r>
+            <a:endParaRPr lang="en-US" sz="1500" dirty="0"/>
+          </a:p>
+        </p:txBody>
+      </p:sp>
+      <p:sp>
+        <p:nvSpPr>
+          <p:cNvPr id="29" name="Winst delen"/>
+          <p:cNvSpPr/>
+          <p:nvPr/>
+        </p:nvSpPr>
+        <p:spPr>
+          <a:xfrm>
+            <a:off x="6278728" y="4069080"/>
+            <a:ext cx="5245456" cy="2011680"/>
+          </a:xfrm>
+          <a:prstGeom prst="roundRect">
+            <a:avLst>
+              <a:gd name="adj" fmla="val 5455"/>
+            </a:avLst>
+          </a:prstGeom>
+          <a:solidFill>
+            <a:schemeClr val="tx1"/>
+          </a:solidFill>
+          <a:ln/>
+        </p:spPr>
+        <p:txBody>
+          <a:bodyPr/>
+          <a:lstStyle/>
+          <a:p>
+            <a:endParaRPr lang="en-US"/>
+          </a:p>
+        </p:txBody>
+      </p:sp>
+      <p:sp>
+        <p:nvSpPr>
+          <p:cNvPr id="30" name="Text 28"/>
+          <p:cNvSpPr txBox="1"/>
+          <p:nvPr/>
+        </p:nvSpPr>
+        <p:spPr>
+          <a:xfrm>
+            <a:off x="6598768" y="4270248"/>
+            <a:ext cx="4605376" cy="457200"/>
+          </a:xfrm>
+          <a:prstGeom prst="rect">
+            <a:avLst/>
+          </a:prstGeom>
+          <a:noFill/>
+          <a:ln/>
+        </p:spPr>
+        <p:txBody>
+          <a:bodyPr wrap="square" lIns="0" tIns="0" rIns="0" bIns="0" rtlCol="0" anchor="ctr"/>
+          <a:lstStyle/>
+          <a:p>
+            <a:pPr marL="0" indent="0">
+              <a:buNone/>
+            </a:pPr>
+            <a:r>
+              <a:rPr lang="en-US" sz="1800" b="1" dirty="0">
+                <a:solidFill>
+                  <a:schemeClr val="bg1"/>
+                </a:solidFill>
+              </a:rPr>
+              <a:t>Winst delen: de prijs dicht bij de kosten</a:t>
+            </a:r>
+            <a:endParaRPr lang="en-US" sz="1800" dirty="0"/>
+          </a:p>
+        </p:txBody>
+      </p:sp>
+      <p:sp>
+        <p:nvSpPr>
+          <p:cNvPr id="31" name="Text 29"/>
+          <p:cNvSpPr txBox="1"/>
+          <p:nvPr/>
+        </p:nvSpPr>
+        <p:spPr>
+          <a:xfrm>
+            <a:off x="6598768" y="4800600"/>
+            <a:ext cx="4605376" cy="1143000"/>
+          </a:xfrm>
+          <a:prstGeom prst="rect">
+            <a:avLst/>
+          </a:prstGeom>
+          <a:noFill/>
+          <a:ln/>
+        </p:spPr>
+        <p:txBody>
+          <a:bodyPr wrap="square" lIns="0" tIns="0" rIns="0" bIns="0" rtlCol="0" anchor="t"/>
+          <a:lstStyle/>
+          <a:p>
+            <a:pPr marL="0" indent="0">
+              <a:buNone/>
+            </a:pPr>
+            <a:r>
+              <a:rPr lang="en-US" sz="1500" dirty="0">
+                <a:solidFill>
+                  <a:schemeClr val="bg2"/>
+                </a:solidFill>
+              </a:rPr>
+              <a:t>Zo veel mogelijk mensen bereikt, voor zo weinig mogelijk geld. De winst blijft bij ons allemaal, en betaalt de volgende stap.</a:t>
+            </a:r>
+            <a:endParaRPr lang="en-US" sz="1500" dirty="0"/>
+          </a:p>
+        </p:txBody>
+      </p:sp>
+      <p:sp>
+        <p:nvSpPr>
+          <p:cNvPr id="32" name="Slide Number Placeholder 0"/>
+          <p:cNvSpPr>
+            <a:spLocks noGrp="1"/>
+          </p:cNvSpPr>
+          <p:nvPr>
+            <p:ph type="sldNum" sz="quarter" idx="4294967295"/>
+          </p:nvPr>
+        </p:nvSpPr>
+        <p:spPr>
+          <a:xfrm>
+            <a:off x="11384280" y="6473952"/>
+            <a:ext cx="457200" cy="228600"/>
+          </a:xfrm>
+          <a:prstGeom prst="rect">
+            <a:avLst/>
+          </a:prstGeom>
+          <a:extLst>
+            <a:ext uri="{C572A759-6A51-4108-AA02-DFA0A04FC94B}">
+              <ma14:wrappingTextBoxFlag xmlns:ma14="http://schemas.microsoft.com/office/mac/drawingml/2011/main" xmlns="" val="0"/>
+            </a:ext>
+          </a:extLst>
+        </p:spPr>
+        <p:txBody>
+          <a:bodyPr/>
+          <a:lstStyle>
+            <a:lvl1pPr>
+              <a:defRPr sz="900">
+                <a:solidFill>
+                  <a:srgbClr val="556675"/>
+                </a:solidFill>
+              </a:defRPr>
+            </a:lvl1pPr>
+          </a:lstStyle>
+          <a:p>
+            <a:pPr algn="r"/>
+            <a:fld id="{F7021451-1387-4CA6-816F-3879F97B5CBC}" type="slidenum">
+              <a:rPr lang="en-US" b="0"/>
+              <a:t>22</a:t>
+            </a:fld>
+            <a:endParaRPr lang="en-US"/>
+          </a:p>
+        </p:txBody>
+      </p:sp>
+    </p:spTree>
+  </p:cSld>
+  <p:clrMapOvr>
+    <a:masterClrMapping/>
+  </p:clrMapOvr>
+</p:sld>
+</file>
+
+<file path=ppt/slides/slide23.xml><?xml version="1.0" encoding="utf-8"?>
 <p:sld xmlns:a="http://schemas.openxmlformats.org/drawingml/2006/main" xmlns:r="http://schemas.openxmlformats.org/officeDocument/2006/relationships" xmlns:p="http://schemas.openxmlformats.org/presentationml/2006/main">
   <p:cSld name="Slide 21">
     <p:spTree>
@@ -10168,7 +12335,95 @@
                   <a:schemeClr val="bg2"/>
                 </a:solidFill>
               </a:rPr>
-              <a:t>Samen, als we eerlijk zijn over wat we zien en durven toe te geven wat we fout zagen, kijken we generaties vooruit.</a:t>
+              <a:t>Samen, als we eerlijk zijn over wat we zien en durven toe te geven wat we fout zagen, kijken we </a:t>
+            </a:r>
+            <a:r>
+              <a:rPr lang="en-US" sz="2000" dirty="0" err="1">
+                <a:solidFill>
+                  <a:schemeClr val="bg2"/>
+                </a:solidFill>
+              </a:rPr>
+              <a:t>generaties</a:t>
+            </a:r>
+            <a:r>
+              <a:rPr lang="en-US" sz="2000" dirty="0">
+                <a:solidFill>
+                  <a:schemeClr val="bg2"/>
+                </a:solidFill>
+              </a:rPr>
+              <a:t> </a:t>
+            </a:r>
+            <a:r>
+              <a:rPr lang="en-US" sz="2000" dirty="0" err="1">
+                <a:solidFill>
+                  <a:schemeClr val="bg2"/>
+                </a:solidFill>
+              </a:rPr>
+              <a:t>vooruit</a:t>
+            </a:r>
+            <a:r>
+              <a:rPr lang="en-US" sz="2000" dirty="0">
+                <a:solidFill>
+                  <a:schemeClr val="bg2"/>
+                </a:solidFill>
+              </a:rPr>
+              <a:t> </a:t>
+            </a:r>
+            <a:r>
+              <a:rPr lang="en-US" sz="2000" dirty="0" err="1">
+                <a:solidFill>
+                  <a:schemeClr val="bg2"/>
+                </a:solidFill>
+              </a:rPr>
+              <a:t>en</a:t>
+            </a:r>
+            <a:r>
+              <a:rPr lang="en-US" sz="2000" dirty="0">
+                <a:solidFill>
+                  <a:schemeClr val="bg2"/>
+                </a:solidFill>
+              </a:rPr>
+              <a:t> </a:t>
+            </a:r>
+            <a:r>
+              <a:rPr lang="en-US" sz="2000" dirty="0" err="1">
+                <a:solidFill>
+                  <a:schemeClr val="bg2"/>
+                </a:solidFill>
+              </a:rPr>
+              <a:t>navigeren</a:t>
+            </a:r>
+            <a:r>
+              <a:rPr lang="en-US" sz="2000" dirty="0">
+                <a:solidFill>
+                  <a:schemeClr val="bg2"/>
+                </a:solidFill>
+              </a:rPr>
+              <a:t> we de </a:t>
+            </a:r>
+            <a:r>
+              <a:rPr lang="en-US" sz="2000" dirty="0" err="1">
+                <a:solidFill>
+                  <a:schemeClr val="bg2"/>
+                </a:solidFill>
+              </a:rPr>
+              <a:t>toekomst</a:t>
+            </a:r>
+            <a:r>
+              <a:rPr lang="en-US" sz="2000" dirty="0">
+                <a:solidFill>
+                  <a:schemeClr val="bg2"/>
+                </a:solidFill>
+              </a:rPr>
+              <a:t>. </a:t>
+            </a:r>
+            <a:r>
+              <a:rPr lang="en-US" dirty="0" err="1"/>
+              <a:t>Kwalitijd</a:t>
+            </a:r>
+            <a:r>
+              <a:rPr lang="en-US" dirty="0"/>
+              <a:t>.</a:t>
             </a:r>
             <a:endParaRPr lang="en-US" sz="2000" dirty="0"/>
           </a:p>
@@ -10405,7 +12660,7 @@
 </p:sld>
 </file>
 
-<file path=ppt/slides/slide22.xml><?xml version="1.0" encoding="utf-8"?>
+<file path=ppt/slides/slide24.xml><?xml version="1.0" encoding="utf-8"?>
 <p:sld xmlns:a="http://schemas.openxmlformats.org/drawingml/2006/main" xmlns:r="http://schemas.openxmlformats.org/officeDocument/2006/relationships" xmlns:p="http://schemas.openxmlformats.org/presentationml/2006/main">
   <p:cSld name="Slide 22">
     <p:spTree>
@@ -10853,7 +13108,7 @@
           </a:prstGeom>
           <a:extLst>
             <a:ext uri="{C572A759-6A51-4108-AA02-DFA0A04FC94B}">
-              <ma14:wrappingTextBoxFlag xmlns:ma14="http://schemas.microsoft.com/office/mac/drawingml/2011/main" xmlns="" val="0"/>
+              <ma14:wrappingTextBoxFlag xmlns="" xmlns:ma14="http://schemas.microsoft.com/office/mac/drawingml/2011/main" val="0"/>
             </a:ext>
           </a:extLst>
         </p:spPr>
@@ -10872,7 +13127,7 @@
             <a:pPr algn="r"/>
             <a:fld id="{F7021451-1387-4CA6-816F-3879F97B5CBC}" type="slidenum">
               <a:rPr lang="en-US" b="0"/>
-              <a:t>22</a:t>
+              <a:t>24</a:t>
             </a:fld>
             <a:endParaRPr lang="en-US"/>
           </a:p>
@@ -11463,7 +13718,7 @@
           </a:prstGeom>
           <a:extLst>
             <a:ext uri="{C572A759-6A51-4108-AA02-DFA0A04FC94B}">
-              <ma14:wrappingTextBoxFlag xmlns:ma14="http://schemas.microsoft.com/office/mac/drawingml/2011/main" xmlns="" val="0"/>
+              <ma14:wrappingTextBoxFlag xmlns="" xmlns:ma14="http://schemas.microsoft.com/office/mac/drawingml/2011/main" val="0"/>
             </a:ext>
           </a:extLst>
         </p:spPr>
@@ -12294,7 +14549,7 @@
           </a:prstGeom>
           <a:extLst>
             <a:ext uri="{C572A759-6A51-4108-AA02-DFA0A04FC94B}">
-              <ma14:wrappingTextBoxFlag xmlns:ma14="http://schemas.microsoft.com/office/mac/drawingml/2011/main" xmlns="" val="0"/>
+              <ma14:wrappingTextBoxFlag xmlns="" xmlns:ma14="http://schemas.microsoft.com/office/mac/drawingml/2011/main" val="0"/>
             </a:ext>
           </a:extLst>
         </p:spPr>
@@ -12998,7 +15253,7 @@
           </a:prstGeom>
           <a:extLst>
             <a:ext uri="{C572A759-6A51-4108-AA02-DFA0A04FC94B}">
-              <ma14:wrappingTextBoxFlag xmlns:ma14="http://schemas.microsoft.com/office/mac/drawingml/2011/main" xmlns="" val="0"/>
+              <ma14:wrappingTextBoxFlag xmlns="" xmlns:ma14="http://schemas.microsoft.com/office/mac/drawingml/2011/main" val="0"/>
             </a:ext>
           </a:extLst>
         </p:spPr>
@@ -14131,7 +16386,7 @@
           </a:prstGeom>
           <a:extLst>
             <a:ext uri="{C572A759-6A51-4108-AA02-DFA0A04FC94B}">
-              <ma14:wrappingTextBoxFlag xmlns:ma14="http://schemas.microsoft.com/office/mac/drawingml/2011/main" xmlns="" val="0"/>
+              <ma14:wrappingTextBoxFlag xmlns="" xmlns:ma14="http://schemas.microsoft.com/office/mac/drawingml/2011/main" val="0"/>
             </a:ext>
           </a:extLst>
         </p:spPr>
@@ -15024,7 +17279,7 @@
           </a:prstGeom>
           <a:extLst>
             <a:ext uri="{C572A759-6A51-4108-AA02-DFA0A04FC94B}">
-              <ma14:wrappingTextBoxFlag xmlns:ma14="http://schemas.microsoft.com/office/mac/drawingml/2011/main" xmlns="" val="0"/>
+              <ma14:wrappingTextBoxFlag xmlns="" xmlns:ma14="http://schemas.microsoft.com/office/mac/drawingml/2011/main" val="0"/>
             </a:ext>
           </a:extLst>
         </p:spPr>
@@ -15650,7 +17905,7 @@
           </a:prstGeom>
           <a:extLst>
             <a:ext uri="{C572A759-6A51-4108-AA02-DFA0A04FC94B}">
-              <ma14:wrappingTextBoxFlag xmlns:ma14="http://schemas.microsoft.com/office/mac/drawingml/2011/main" xmlns="" val="0"/>
+              <ma14:wrappingTextBoxFlag xmlns="" xmlns:ma14="http://schemas.microsoft.com/office/mac/drawingml/2011/main" val="0"/>
             </a:ext>
           </a:extLst>
         </p:spPr>
@@ -16094,7 +18349,7 @@
           </a:prstGeom>
           <a:extLst>
             <a:ext uri="{C572A759-6A51-4108-AA02-DFA0A04FC94B}">
-              <ma14:wrappingTextBoxFlag xmlns:ma14="http://schemas.microsoft.com/office/mac/drawingml/2011/main" xmlns="" val="0"/>
+              <ma14:wrappingTextBoxFlag xmlns="" xmlns:ma14="http://schemas.microsoft.com/office/mac/drawingml/2011/main" val="0"/>
             </a:ext>
           </a:extLst>
         </p:spPr>

</xml_diff>